<commit_message>
Redesign objectives and show equipment inputs alongside cooling result
</commit_message>
<xml_diff>
--- a/presentation/operator-dng-revision2/OperatorDNG_Presentation_Revision2.pptx
+++ b/presentation/operator-dng-revision2/OperatorDNG_Presentation_Revision2.pptx
@@ -50423,7 +50423,7 @@
               <a:spcAft>
                 <a:spcPts val="700"/>
               </a:spcAft>
-              <a:defRPr sz="3600" b="1">
+              <a:defRPr sz="4275" b="1">
                 <a:solidFill>
                   <a:srgbClr val="FFFFFF"/>
                 </a:solidFill>
@@ -50431,52 +50431,63 @@
               </a:defRPr>
             </a:pPr>
             <a:r>
-              <a:t>Четыре задачи. Один помощник.</a:t>
+              <a:t>Задачи проекта</a:t>
             </a:r>
           </a:p>
         </p:txBody>
       </p:sp>
       <p:sp>
         <p:nvSpPr>
-          <p:cNvPr id="3" name="!!ObjectiveCard0"/>
-          <p:cNvSpPr/>
+          <p:cNvPr id="3" name="!!TaskNumber0"/>
+          <p:cNvSpPr txBox="1"/>
           <p:nvPr/>
         </p:nvSpPr>
         <p:spPr>
           <a:xfrm>
-            <a:off x="666750" y="2428875"/>
-            <a:ext cx="2571750" cy="3667125"/>
-          </a:xfrm>
-          <a:prstGeom prst="roundRect">
-            <a:avLst>
-              <a:gd name="adj" fmla="val 3500"/>
-            </a:avLst>
+            <a:off x="723900" y="2762250"/>
+            <a:ext cx="762000" cy="619125"/>
+          </a:xfrm>
+          <a:prstGeom prst="rect">
+            <a:avLst/>
           </a:prstGeom>
-          <a:solidFill>
-            <a:srgbClr val="FFFFFF"/>
-          </a:solidFill>
-          <a:ln>
-            <a:noFill/>
-          </a:ln>
+          <a:noFill/>
         </p:spPr>
         <p:txBody>
-          <a:bodyPr rtlCol="0" anchor="ctr"/>
+          <a:bodyPr wrap="square" lIns="0" rIns="0" tIns="0" bIns="0">
+            <a:spAutoFit/>
+          </a:bodyPr>
           <a:lstStyle/>
           <a:p>
-            <a:pPr algn="ctr"/>
+            <a:pPr>
+              <a:lnSpc>
+                <a:spcPct val="104000"/>
+              </a:lnSpc>
+              <a:spcAft>
+                <a:spcPts val="700"/>
+              </a:spcAft>
+              <a:defRPr sz="3600" b="1">
+                <a:solidFill>
+                  <a:srgbClr val="FFCD00"/>
+                </a:solidFill>
+                <a:latin typeface="Arial"/>
+              </a:defRPr>
+            </a:pPr>
+            <a:r>
+              <a:t>01</a:t>
+            </a:r>
           </a:p>
         </p:txBody>
       </p:sp>
       <p:sp>
         <p:nvSpPr>
-          <p:cNvPr id="4" name="Block_3"/>
+          <p:cNvPr id="4" name="TaskRule0"/>
           <p:cNvSpPr/>
           <p:nvPr/>
         </p:nvSpPr>
         <p:spPr>
           <a:xfrm>
-            <a:off x="666750" y="2428875"/>
-            <a:ext cx="2571750" cy="57150"/>
+            <a:off x="1619250" y="2800350"/>
+            <a:ext cx="28575" cy="1247775"/>
           </a:xfrm>
           <a:prstGeom prst="rect">
             <a:avLst/>
@@ -50498,14 +50509,14 @@
       </p:sp>
       <p:sp>
         <p:nvSpPr>
-          <p:cNvPr id="5" name="TaskNumber0"/>
+          <p:cNvPr id="5" name="!!TaskTitle0"/>
           <p:cNvSpPr txBox="1"/>
           <p:nvPr/>
         </p:nvSpPr>
         <p:spPr>
           <a:xfrm>
-            <a:off x="800100" y="2600325"/>
-            <a:ext cx="361950" cy="323850"/>
+            <a:off x="1866899" y="2762250"/>
+            <a:ext cx="4048124" cy="952500"/>
           </a:xfrm>
           <a:prstGeom prst="rect">
             <a:avLst/>
@@ -50525,29 +50536,29 @@
               <a:spcAft>
                 <a:spcPts val="700"/>
               </a:spcAft>
-              <a:defRPr sz="1875" b="1">
+              <a:defRPr sz="2100" b="1">
                 <a:solidFill>
-                  <a:srgbClr val="000000"/>
+                  <a:srgbClr val="FFFFFF"/>
                 </a:solidFill>
                 <a:latin typeface="Arial"/>
               </a:defRPr>
             </a:pPr>
             <a:r>
-              <a:t>01</a:t>
+              <a:t>Объединить рабочие инструменты</a:t>
             </a:r>
           </a:p>
         </p:txBody>
       </p:sp>
       <p:sp>
         <p:nvSpPr>
-          <p:cNvPr id="6" name="TaskTitle0"/>
+          <p:cNvPr id="6" name="TaskDescription0"/>
           <p:cNvSpPr txBox="1"/>
           <p:nvPr/>
         </p:nvSpPr>
         <p:spPr>
           <a:xfrm>
-            <a:off x="1209675" y="2600325"/>
-            <a:ext cx="1885950" cy="1219200"/>
+            <a:off x="1866899" y="3790949"/>
+            <a:ext cx="4048124" cy="619125"/>
           </a:xfrm>
           <a:prstGeom prst="rect">
             <a:avLst/>
@@ -50567,85 +50578,71 @@
               <a:spcAft>
                 <a:spcPts val="700"/>
               </a:spcAft>
-              <a:defRPr sz="1500" b="1">
+              <a:defRPr sz="1425" b="0">
                 <a:solidFill>
-                  <a:srgbClr val="000000"/>
+                  <a:srgbClr val="B7B7B7"/>
                 </a:solidFill>
                 <a:latin typeface="Arial"/>
               </a:defRPr>
             </a:pPr>
             <a:r>
-              <a:t>Объединить рабочие инструменты</a:t>
+              <a:t>собрать расчёты, инструкции и справочные материалы в одном приложении.</a:t>
             </a:r>
-          </a:p>
-        </p:txBody>
-      </p:sp>
-      <p:pic>
-        <p:nvPicPr>
-          <p:cNvPr id="7" name="ObjectiveImage0" descr="home.png"/>
-          <p:cNvPicPr>
-            <a:picLocks noChangeAspect="1"/>
-          </p:cNvPicPr>
-          <p:nvPr/>
-        </p:nvPicPr>
-        <p:blipFill>
-          <a:blip r:embed="rId2"/>
-          <a:srcRect/>
-          <a:stretch>
-            <a:fillRect/>
-          </a:stretch>
-        </p:blipFill>
-        <p:spPr>
-          <a:xfrm>
-            <a:off x="1479478" y="3914775"/>
-            <a:ext cx="946292" cy="2047875"/>
-          </a:xfrm>
-          <a:prstGeom prst="rect">
-            <a:avLst/>
-          </a:prstGeom>
-        </p:spPr>
-      </p:pic>
-      <p:sp>
-        <p:nvSpPr>
-          <p:cNvPr id="8" name="!!ObjectiveCard1"/>
-          <p:cNvSpPr/>
-          <p:nvPr/>
-        </p:nvSpPr>
-        <p:spPr>
-          <a:xfrm>
-            <a:off x="3429000" y="2428875"/>
-            <a:ext cx="2571750" cy="3667125"/>
-          </a:xfrm>
-          <a:prstGeom prst="roundRect">
-            <a:avLst>
-              <a:gd name="adj" fmla="val 3500"/>
-            </a:avLst>
-          </a:prstGeom>
-          <a:solidFill>
-            <a:srgbClr val="FFFFFF"/>
-          </a:solidFill>
-          <a:ln>
-            <a:noFill/>
-          </a:ln>
-        </p:spPr>
-        <p:txBody>
-          <a:bodyPr rtlCol="0" anchor="ctr"/>
-          <a:lstStyle/>
-          <a:p>
-            <a:pPr algn="ctr"/>
           </a:p>
         </p:txBody>
       </p:sp>
       <p:sp>
         <p:nvSpPr>
-          <p:cNvPr id="9" name="Block_8"/>
-          <p:cNvSpPr/>
+          <p:cNvPr id="7" name="!!TaskNumber1"/>
+          <p:cNvSpPr txBox="1"/>
           <p:nvPr/>
         </p:nvSpPr>
         <p:spPr>
           <a:xfrm>
-            <a:off x="3429000" y="2428875"/>
-            <a:ext cx="2571750" cy="57150"/>
+            <a:off x="6343650" y="2762250"/>
+            <a:ext cx="762000" cy="619125"/>
+          </a:xfrm>
+          <a:prstGeom prst="rect">
+            <a:avLst/>
+          </a:prstGeom>
+          <a:noFill/>
+        </p:spPr>
+        <p:txBody>
+          <a:bodyPr wrap="square" lIns="0" rIns="0" tIns="0" bIns="0">
+            <a:spAutoFit/>
+          </a:bodyPr>
+          <a:lstStyle/>
+          <a:p>
+            <a:pPr>
+              <a:lnSpc>
+                <a:spcPct val="104000"/>
+              </a:lnSpc>
+              <a:spcAft>
+                <a:spcPts val="700"/>
+              </a:spcAft>
+              <a:defRPr sz="3600" b="1">
+                <a:solidFill>
+                  <a:srgbClr val="FFCD00"/>
+                </a:solidFill>
+                <a:latin typeface="Arial"/>
+              </a:defRPr>
+            </a:pPr>
+            <a:r>
+              <a:t>02</a:t>
+            </a:r>
+          </a:p>
+        </p:txBody>
+      </p:sp>
+      <p:sp>
+        <p:nvSpPr>
+          <p:cNvPr id="8" name="TaskRule1"/>
+          <p:cNvSpPr/>
+          <p:nvPr/>
+        </p:nvSpPr>
+        <p:spPr>
+          <a:xfrm>
+            <a:off x="7239000" y="2800350"/>
+            <a:ext cx="28575" cy="1247775"/>
           </a:xfrm>
           <a:prstGeom prst="rect">
             <a:avLst/>
@@ -50667,14 +50664,14 @@
       </p:sp>
       <p:sp>
         <p:nvSpPr>
-          <p:cNvPr id="10" name="TaskNumber1"/>
+          <p:cNvPr id="9" name="!!TaskTitle1"/>
           <p:cNvSpPr txBox="1"/>
           <p:nvPr/>
         </p:nvSpPr>
         <p:spPr>
           <a:xfrm>
-            <a:off x="3562350" y="2600325"/>
-            <a:ext cx="361950" cy="323850"/>
+            <a:off x="7486650" y="2762250"/>
+            <a:ext cx="4048124" cy="952500"/>
           </a:xfrm>
           <a:prstGeom prst="rect">
             <a:avLst/>
@@ -50694,29 +50691,29 @@
               <a:spcAft>
                 <a:spcPts val="700"/>
               </a:spcAft>
-              <a:defRPr sz="1875" b="1">
+              <a:defRPr sz="2100" b="1">
                 <a:solidFill>
-                  <a:srgbClr val="000000"/>
+                  <a:srgbClr val="FFFFFF"/>
                 </a:solidFill>
                 <a:latin typeface="Arial"/>
               </a:defRPr>
             </a:pPr>
             <a:r>
-              <a:t>02</a:t>
+              <a:t>Упростить ежедневные расчёты и замеры</a:t>
             </a:r>
           </a:p>
         </p:txBody>
       </p:sp>
       <p:sp>
         <p:nvSpPr>
-          <p:cNvPr id="11" name="TaskTitle1"/>
+          <p:cNvPr id="10" name="TaskDescription1"/>
           <p:cNvSpPr txBox="1"/>
           <p:nvPr/>
         </p:nvSpPr>
         <p:spPr>
           <a:xfrm>
-            <a:off x="3971925" y="2600325"/>
-            <a:ext cx="1885950" cy="1219200"/>
+            <a:off x="7486650" y="3790949"/>
+            <a:ext cx="4048124" cy="619125"/>
           </a:xfrm>
           <a:prstGeom prst="rect">
             <a:avLst/>
@@ -50736,85 +50733,71 @@
               <a:spcAft>
                 <a:spcPts val="700"/>
               </a:spcAft>
-              <a:defRPr sz="1500" b="1">
+              <a:defRPr sz="1425" b="0">
                 <a:solidFill>
-                  <a:srgbClr val="000000"/>
+                  <a:srgbClr val="B7B7B7"/>
                 </a:solidFill>
                 <a:latin typeface="Arial"/>
               </a:defRPr>
             </a:pPr>
             <a:r>
-              <a:t>Упростить ежедневные расчёты и замеры</a:t>
+              <a:t>автоматизировать вычисления, отсчёт времени и сохранение результатов.</a:t>
             </a:r>
-          </a:p>
-        </p:txBody>
-      </p:sp>
-      <p:pic>
-        <p:nvPicPr>
-          <p:cNvPr id="12" name="ObjectiveImage1" descr="manual-minutes.png"/>
-          <p:cNvPicPr>
-            <a:picLocks noChangeAspect="1"/>
-          </p:cNvPicPr>
-          <p:nvPr/>
-        </p:nvPicPr>
-        <p:blipFill>
-          <a:blip r:embed="rId3"/>
-          <a:srcRect/>
-          <a:stretch>
-            <a:fillRect/>
-          </a:stretch>
-        </p:blipFill>
-        <p:spPr>
-          <a:xfrm>
-            <a:off x="4241728" y="3914775"/>
-            <a:ext cx="946292" cy="2047875"/>
-          </a:xfrm>
-          <a:prstGeom prst="rect">
-            <a:avLst/>
-          </a:prstGeom>
-        </p:spPr>
-      </p:pic>
-      <p:sp>
-        <p:nvSpPr>
-          <p:cNvPr id="13" name="!!ObjectiveCard2"/>
-          <p:cNvSpPr/>
-          <p:nvPr/>
-        </p:nvSpPr>
-        <p:spPr>
-          <a:xfrm>
-            <a:off x="6191250" y="2428875"/>
-            <a:ext cx="2571750" cy="3667125"/>
-          </a:xfrm>
-          <a:prstGeom prst="roundRect">
-            <a:avLst>
-              <a:gd name="adj" fmla="val 3500"/>
-            </a:avLst>
-          </a:prstGeom>
-          <a:solidFill>
-            <a:srgbClr val="FFFFFF"/>
-          </a:solidFill>
-          <a:ln>
-            <a:noFill/>
-          </a:ln>
-        </p:spPr>
-        <p:txBody>
-          <a:bodyPr rtlCol="0" anchor="ctr"/>
-          <a:lstStyle/>
-          <a:p>
-            <a:pPr algn="ctr"/>
           </a:p>
         </p:txBody>
       </p:sp>
       <p:sp>
         <p:nvSpPr>
-          <p:cNvPr id="14" name="Block_13"/>
-          <p:cNvSpPr/>
+          <p:cNvPr id="11" name="!!TaskNumber2"/>
+          <p:cNvSpPr txBox="1"/>
           <p:nvPr/>
         </p:nvSpPr>
         <p:spPr>
           <a:xfrm>
-            <a:off x="6191250" y="2428875"/>
-            <a:ext cx="2571750" cy="57150"/>
+            <a:off x="723900" y="4505325"/>
+            <a:ext cx="762000" cy="619125"/>
+          </a:xfrm>
+          <a:prstGeom prst="rect">
+            <a:avLst/>
+          </a:prstGeom>
+          <a:noFill/>
+        </p:spPr>
+        <p:txBody>
+          <a:bodyPr wrap="square" lIns="0" rIns="0" tIns="0" bIns="0">
+            <a:spAutoFit/>
+          </a:bodyPr>
+          <a:lstStyle/>
+          <a:p>
+            <a:pPr>
+              <a:lnSpc>
+                <a:spcPct val="104000"/>
+              </a:lnSpc>
+              <a:spcAft>
+                <a:spcPts val="700"/>
+              </a:spcAft>
+              <a:defRPr sz="3600" b="1">
+                <a:solidFill>
+                  <a:srgbClr val="FFCD00"/>
+                </a:solidFill>
+                <a:latin typeface="Arial"/>
+              </a:defRPr>
+            </a:pPr>
+            <a:r>
+              <a:t>03</a:t>
+            </a:r>
+          </a:p>
+        </p:txBody>
+      </p:sp>
+      <p:sp>
+        <p:nvSpPr>
+          <p:cNvPr id="12" name="TaskRule2"/>
+          <p:cNvSpPr/>
+          <p:nvPr/>
+        </p:nvSpPr>
+        <p:spPr>
+          <a:xfrm>
+            <a:off x="1619250" y="4543425"/>
+            <a:ext cx="28575" cy="1247775"/>
           </a:xfrm>
           <a:prstGeom prst="rect">
             <a:avLst/>
@@ -50836,14 +50819,14 @@
       </p:sp>
       <p:sp>
         <p:nvSpPr>
-          <p:cNvPr id="15" name="TaskNumber2"/>
+          <p:cNvPr id="13" name="!!TaskTitle2"/>
           <p:cNvSpPr txBox="1"/>
           <p:nvPr/>
         </p:nvSpPr>
         <p:spPr>
           <a:xfrm>
-            <a:off x="6324600" y="2600325"/>
-            <a:ext cx="361950" cy="323850"/>
+            <a:off x="1866899" y="4505325"/>
+            <a:ext cx="4048124" cy="952500"/>
           </a:xfrm>
           <a:prstGeom prst="rect">
             <a:avLst/>
@@ -50863,29 +50846,29 @@
               <a:spcAft>
                 <a:spcPts val="700"/>
               </a:spcAft>
-              <a:defRPr sz="1875" b="1">
+              <a:defRPr sz="2100" b="1">
                 <a:solidFill>
-                  <a:srgbClr val="000000"/>
+                  <a:srgbClr val="FFFFFF"/>
                 </a:solidFill>
                 <a:latin typeface="Arial"/>
               </a:defRPr>
             </a:pPr>
             <a:r>
-              <a:t>03</a:t>
+              <a:t>Помочь соблюдать последовательность действий</a:t>
             </a:r>
           </a:p>
         </p:txBody>
       </p:sp>
       <p:sp>
         <p:nvSpPr>
-          <p:cNvPr id="16" name="TaskTitle2"/>
+          <p:cNvPr id="14" name="TaskDescription2"/>
           <p:cNvSpPr txBox="1"/>
           <p:nvPr/>
         </p:nvSpPr>
         <p:spPr>
           <a:xfrm>
-            <a:off x="6734175" y="2600325"/>
-            <a:ext cx="1885950" cy="1219200"/>
+            <a:off x="1866899" y="5534025"/>
+            <a:ext cx="4048124" cy="619125"/>
           </a:xfrm>
           <a:prstGeom prst="rect">
             <a:avLst/>
@@ -50905,85 +50888,71 @@
               <a:spcAft>
                 <a:spcPts val="700"/>
               </a:spcAft>
-              <a:defRPr sz="1500" b="1">
+              <a:defRPr sz="1425" b="0">
                 <a:solidFill>
-                  <a:srgbClr val="000000"/>
+                  <a:srgbClr val="B7B7B7"/>
                 </a:solidFill>
                 <a:latin typeface="Arial"/>
               </a:defRPr>
             </a:pPr>
             <a:r>
-              <a:t>Помочь соблюдать последовательность действий</a:t>
+              <a:t>предоставить инструкции и фотографии для конкретных моделей станций управления.</a:t>
             </a:r>
-          </a:p>
-        </p:txBody>
-      </p:sp>
-      <p:pic>
-        <p:nvPicPr>
-          <p:cNvPr id="17" name="ObjectiveImage2" descr="ramp.png"/>
-          <p:cNvPicPr>
-            <a:picLocks noChangeAspect="1"/>
-          </p:cNvPicPr>
-          <p:nvPr/>
-        </p:nvPicPr>
-        <p:blipFill>
-          <a:blip r:embed="rId4"/>
-          <a:srcRect/>
-          <a:stretch>
-            <a:fillRect/>
-          </a:stretch>
-        </p:blipFill>
-        <p:spPr>
-          <a:xfrm>
-            <a:off x="7003978" y="3914775"/>
-            <a:ext cx="946292" cy="2047875"/>
-          </a:xfrm>
-          <a:prstGeom prst="rect">
-            <a:avLst/>
-          </a:prstGeom>
-        </p:spPr>
-      </p:pic>
-      <p:sp>
-        <p:nvSpPr>
-          <p:cNvPr id="18" name="!!ObjectiveCard3"/>
-          <p:cNvSpPr/>
-          <p:nvPr/>
-        </p:nvSpPr>
-        <p:spPr>
-          <a:xfrm>
-            <a:off x="8953500" y="2428875"/>
-            <a:ext cx="2571750" cy="3667125"/>
-          </a:xfrm>
-          <a:prstGeom prst="roundRect">
-            <a:avLst>
-              <a:gd name="adj" fmla="val 3500"/>
-            </a:avLst>
-          </a:prstGeom>
-          <a:solidFill>
-            <a:srgbClr val="FFFFFF"/>
-          </a:solidFill>
-          <a:ln>
-            <a:noFill/>
-          </a:ln>
-        </p:spPr>
-        <p:txBody>
-          <a:bodyPr rtlCol="0" anchor="ctr"/>
-          <a:lstStyle/>
-          <a:p>
-            <a:pPr algn="ctr"/>
           </a:p>
         </p:txBody>
       </p:sp>
       <p:sp>
         <p:nvSpPr>
-          <p:cNvPr id="19" name="Block_18"/>
-          <p:cNvSpPr/>
+          <p:cNvPr id="15" name="!!TaskNumber3"/>
+          <p:cNvSpPr txBox="1"/>
           <p:nvPr/>
         </p:nvSpPr>
         <p:spPr>
           <a:xfrm>
-            <a:off x="8953500" y="2428875"/>
-            <a:ext cx="2571750" cy="57150"/>
+            <a:off x="6343650" y="4505325"/>
+            <a:ext cx="762000" cy="619125"/>
+          </a:xfrm>
+          <a:prstGeom prst="rect">
+            <a:avLst/>
+          </a:prstGeom>
+          <a:noFill/>
+        </p:spPr>
+        <p:txBody>
+          <a:bodyPr wrap="square" lIns="0" rIns="0" tIns="0" bIns="0">
+            <a:spAutoFit/>
+          </a:bodyPr>
+          <a:lstStyle/>
+          <a:p>
+            <a:pPr>
+              <a:lnSpc>
+                <a:spcPct val="104000"/>
+              </a:lnSpc>
+              <a:spcAft>
+                <a:spcPts val="700"/>
+              </a:spcAft>
+              <a:defRPr sz="3600" b="1">
+                <a:solidFill>
+                  <a:srgbClr val="FFCD00"/>
+                </a:solidFill>
+                <a:latin typeface="Arial"/>
+              </a:defRPr>
+            </a:pPr>
+            <a:r>
+              <a:t>04</a:t>
+            </a:r>
+          </a:p>
+        </p:txBody>
+      </p:sp>
+      <p:sp>
+        <p:nvSpPr>
+          <p:cNvPr id="16" name="TaskRule3"/>
+          <p:cNvSpPr/>
+          <p:nvPr/>
+        </p:nvSpPr>
+        <p:spPr>
+          <a:xfrm>
+            <a:off x="7239000" y="4543425"/>
+            <a:ext cx="28575" cy="1247775"/>
           </a:xfrm>
           <a:prstGeom prst="rect">
             <a:avLst/>
@@ -51005,14 +50974,14 @@
       </p:sp>
       <p:sp>
         <p:nvSpPr>
-          <p:cNvPr id="20" name="TaskNumber3"/>
+          <p:cNvPr id="17" name="!!TaskTitle3"/>
           <p:cNvSpPr txBox="1"/>
           <p:nvPr/>
         </p:nvSpPr>
         <p:spPr>
           <a:xfrm>
-            <a:off x="9086850" y="2600325"/>
-            <a:ext cx="361950" cy="323850"/>
+            <a:off x="7486650" y="4505325"/>
+            <a:ext cx="4048124" cy="952500"/>
           </a:xfrm>
           <a:prstGeom prst="rect">
             <a:avLst/>
@@ -51032,29 +51001,29 @@
               <a:spcAft>
                 <a:spcPts val="700"/>
               </a:spcAft>
-              <a:defRPr sz="1875" b="1">
+              <a:defRPr sz="2100" b="1">
                 <a:solidFill>
-                  <a:srgbClr val="000000"/>
+                  <a:srgbClr val="FFFFFF"/>
                 </a:solidFill>
                 <a:latin typeface="Arial"/>
               </a:defRPr>
             </a:pPr>
             <a:r>
-              <a:t>04</a:t>
+              <a:t>Обеспечить быстрый доступ к информации на промысле</a:t>
             </a:r>
           </a:p>
         </p:txBody>
       </p:sp>
       <p:sp>
         <p:nvSpPr>
-          <p:cNvPr id="21" name="TaskTitle3"/>
+          <p:cNvPr id="18" name="TaskDescription3"/>
           <p:cNvSpPr txBox="1"/>
           <p:nvPr/>
         </p:nvSpPr>
         <p:spPr>
           <a:xfrm>
-            <a:off x="9496425" y="2600325"/>
-            <a:ext cx="1885950" cy="1219200"/>
+            <a:off x="7486650" y="5534025"/>
+            <a:ext cx="4048124" cy="619125"/>
           </a:xfrm>
           <a:prstGeom prst="rect">
             <a:avLst/>
@@ -51074,47 +51043,22 @@
               <a:spcAft>
                 <a:spcPts val="700"/>
               </a:spcAft>
-              <a:defRPr sz="1500" b="1">
+              <a:defRPr sz="1425" b="0">
                 <a:solidFill>
-                  <a:srgbClr val="000000"/>
+                  <a:srgbClr val="B7B7B7"/>
                 </a:solidFill>
                 <a:latin typeface="Arial"/>
               </a:defRPr>
             </a:pPr>
             <a:r>
-              <a:t>Обеспечить быстрый доступ к информации на промысле</a:t>
+              <a:t>реализовать поиск, закладки и работу предварительно загруженных материалов без интернета.</a:t>
             </a:r>
           </a:p>
         </p:txBody>
       </p:sp>
-      <p:pic>
-        <p:nvPicPr>
-          <p:cNvPr id="22" name="ObjectiveImage3" descr="vnr.png"/>
-          <p:cNvPicPr>
-            <a:picLocks noChangeAspect="1"/>
-          </p:cNvPicPr>
-          <p:nvPr/>
-        </p:nvPicPr>
-        <p:blipFill>
-          <a:blip r:embed="rId5"/>
-          <a:srcRect/>
-          <a:stretch>
-            <a:fillRect/>
-          </a:stretch>
-        </p:blipFill>
-        <p:spPr>
-          <a:xfrm>
-            <a:off x="9766228" y="3914775"/>
-            <a:ext cx="946292" cy="2047875"/>
-          </a:xfrm>
-          <a:prstGeom prst="rect">
-            <a:avLst/>
-          </a:prstGeom>
-        </p:spPr>
-      </p:pic>
       <p:sp>
         <p:nvSpPr>
-          <p:cNvPr id="23" name="!!Rule"/>
+          <p:cNvPr id="19" name="!!Rule"/>
           <p:cNvSpPr/>
           <p:nvPr/>
         </p:nvSpPr>
@@ -51143,7 +51087,7 @@
       </p:sp>
       <p:sp>
         <p:nvSpPr>
-          <p:cNvPr id="24" name="!!Section"/>
+          <p:cNvPr id="20" name="!!Section"/>
           <p:cNvSpPr txBox="1"/>
           <p:nvPr/>
         </p:nvSpPr>
@@ -51185,7 +51129,7 @@
       </p:sp>
       <p:sp>
         <p:nvSpPr>
-          <p:cNvPr id="25" name="!!Footer"/>
+          <p:cNvPr id="21" name="!!Footer"/>
           <p:cNvSpPr txBox="1"/>
           <p:nvPr/>
         </p:nvSpPr>
@@ -51227,7 +51171,7 @@
       </p:sp>
       <p:sp>
         <p:nvSpPr>
-          <p:cNvPr id="26" name="SlideNumber"/>
+          <p:cNvPr id="22" name="SlideNumber"/>
           <p:cNvSpPr txBox="1"/>
           <p:nvPr/>
         </p:nvSpPr>
@@ -53564,7 +53508,7 @@
         <p:spPr>
           <a:xfrm>
             <a:off x="685800" y="1476375"/>
-            <a:ext cx="6667500" cy="1619250"/>
+            <a:ext cx="5715000" cy="1619250"/>
           </a:xfrm>
           <a:prstGeom prst="rect">
             <a:avLst/>
@@ -53584,7 +53528,7 @@
               <a:spcAft>
                 <a:spcPts val="700"/>
               </a:spcAft>
-              <a:defRPr sz="3525" b="1">
+              <a:defRPr sz="3375" b="1">
                 <a:solidFill>
                   <a:srgbClr val="FFFFFF"/>
                 </a:solidFill>
@@ -53603,7 +53547,7 @@
               <a:spcAft>
                 <a:spcPts val="700"/>
               </a:spcAft>
-              <a:defRPr sz="3525" b="1">
+              <a:defRPr sz="3375" b="1">
                 <a:solidFill>
                   <a:srgbClr val="FFFFFF"/>
                 </a:solidFill>
@@ -53654,7 +53598,7 @@
         <p:spPr>
           <a:xfrm>
             <a:off x="933449" y="3286125"/>
-            <a:ext cx="6477000" cy="476250"/>
+            <a:ext cx="5476875" cy="476250"/>
           </a:xfrm>
           <a:prstGeom prst="rect">
             <a:avLst/>
@@ -53674,7 +53618,7 @@
               <a:spcAft>
                 <a:spcPts val="700"/>
               </a:spcAft>
-              <a:defRPr sz="1875" b="0">
+              <a:defRPr sz="1725" b="0">
                 <a:solidFill>
                   <a:srgbClr val="FFFFFF"/>
                 </a:solidFill>
@@ -53682,7 +53626,26 @@
               </a:defRPr>
             </a:pPr>
             <a:r>
-              <a:t>Задаём параметры оборудования</a:t>
+              <a:t>Задаём диаметр, мощность,</a:t>
+            </a:r>
+          </a:p>
+          <a:p>
+            <a:pPr>
+              <a:lnSpc>
+                <a:spcPct val="104000"/>
+              </a:lnSpc>
+              <a:spcAft>
+                <a:spcPts val="700"/>
+              </a:spcAft>
+              <a:defRPr sz="1725" b="0">
+                <a:solidFill>
+                  <a:srgbClr val="FFFFFF"/>
+                </a:solidFill>
+                <a:latin typeface="Arial"/>
+              </a:defRPr>
+            </a:pPr>
+            <a:r>
+              <a:t>колонну и толщину стенки</a:t>
             </a:r>
           </a:p>
         </p:txBody>
@@ -53695,7 +53658,7 @@
         </p:nvSpPr>
         <p:spPr>
           <a:xfrm>
-            <a:off x="723900" y="4029075"/>
+            <a:off x="723900" y="4219575"/>
             <a:ext cx="38100" cy="228600"/>
           </a:xfrm>
           <a:prstGeom prst="rect">
@@ -53724,8 +53687,8 @@
         </p:nvSpPr>
         <p:spPr>
           <a:xfrm>
-            <a:off x="933449" y="3962399"/>
-            <a:ext cx="6477000" cy="476250"/>
+            <a:off x="933449" y="4152900"/>
+            <a:ext cx="5476875" cy="476250"/>
           </a:xfrm>
           <a:prstGeom prst="rect">
             <a:avLst/>
@@ -53745,7 +53708,7 @@
               <a:spcAft>
                 <a:spcPts val="700"/>
               </a:spcAft>
-              <a:defRPr sz="1875" b="0">
+              <a:defRPr sz="1725" b="0">
                 <a:solidFill>
                   <a:srgbClr val="FFFFFF"/>
                 </a:solidFill>
@@ -53753,7 +53716,7 @@
               </a:defRPr>
             </a:pPr>
             <a:r>
-              <a:t>Выбираем доступный УЭЦН / ПЭД</a:t>
+              <a:t>Выбираем доступный ПЭД</a:t>
             </a:r>
           </a:p>
         </p:txBody>
@@ -53766,7 +53729,7 @@
         </p:nvSpPr>
         <p:spPr>
           <a:xfrm>
-            <a:off x="723900" y="4705350"/>
+            <a:off x="723900" y="5086350"/>
             <a:ext cx="38100" cy="228600"/>
           </a:xfrm>
           <a:prstGeom prst="rect">
@@ -53795,8 +53758,8 @@
         </p:nvSpPr>
         <p:spPr>
           <a:xfrm>
-            <a:off x="933449" y="4638675"/>
-            <a:ext cx="6477000" cy="476250"/>
+            <a:off x="933449" y="5019675"/>
+            <a:ext cx="5476875" cy="476250"/>
           </a:xfrm>
           <a:prstGeom prst="rect">
             <a:avLst/>
@@ -53816,7 +53779,7 @@
               <a:spcAft>
                 <a:spcPts val="700"/>
               </a:spcAft>
-              <a:defRPr sz="1875" b="0">
+              <a:defRPr sz="1725" b="0">
                 <a:solidFill>
                   <a:srgbClr val="FFFFFF"/>
                 </a:solidFill>
@@ -53824,63 +53787,21 @@
               </a:defRPr>
             </a:pPr>
             <a:r>
-              <a:t>Вводим номинальный и рабочий ток</a:t>
+              <a:t>Вводим токи — получаем приток</a:t>
             </a:r>
           </a:p>
         </p:txBody>
       </p:sp>
       <p:sp>
         <p:nvSpPr>
-          <p:cNvPr id="9" name="Text_8"/>
-          <p:cNvSpPr txBox="1"/>
+          <p:cNvPr id="9" name="ParameterFrame"/>
+          <p:cNvSpPr/>
           <p:nvPr/>
         </p:nvSpPr>
         <p:spPr>
           <a:xfrm>
-            <a:off x="762000" y="5467350"/>
-            <a:ext cx="6381750" cy="590550"/>
-          </a:xfrm>
-          <a:prstGeom prst="rect">
-            <a:avLst/>
-          </a:prstGeom>
-          <a:noFill/>
-        </p:spPr>
-        <p:txBody>
-          <a:bodyPr wrap="square" lIns="0" rIns="0" tIns="0" bIns="0">
-            <a:spAutoFit/>
-          </a:bodyPr>
-          <a:lstStyle/>
-          <a:p>
-            <a:pPr>
-              <a:lnSpc>
-                <a:spcPct val="104000"/>
-              </a:lnSpc>
-              <a:spcAft>
-                <a:spcPts val="700"/>
-              </a:spcAft>
-              <a:defRPr sz="2400" b="1">
-                <a:solidFill>
-                  <a:srgbClr val="FFCD00"/>
-                </a:solidFill>
-                <a:latin typeface="Arial"/>
-              </a:defRPr>
-            </a:pPr>
-            <a:r>
-              <a:t>Получаем необходимый приток</a:t>
-            </a:r>
-          </a:p>
-        </p:txBody>
-      </p:sp>
-      <p:sp>
-        <p:nvSpPr>
-          <p:cNvPr id="10" name="!!DemoWindow"/>
-          <p:cNvSpPr/>
-          <p:nvPr/>
-        </p:nvSpPr>
-        <p:spPr>
-          <a:xfrm>
-            <a:off x="7667624" y="1381125"/>
-            <a:ext cx="3857625" cy="4762500"/>
+            <a:off x="6581775" y="1390650"/>
+            <a:ext cx="2333625" cy="4505325"/>
           </a:xfrm>
           <a:prstGeom prst="roundRect">
             <a:avLst>
@@ -53904,14 +53825,14 @@
       </p:sp>
       <p:sp>
         <p:nvSpPr>
-          <p:cNvPr id="11" name="!!DemoCaption"/>
+          <p:cNvPr id="10" name="Text_9"/>
           <p:cNvSpPr txBox="1"/>
           <p:nvPr/>
         </p:nvSpPr>
         <p:spPr>
           <a:xfrm>
-            <a:off x="7858125" y="1562100"/>
-            <a:ext cx="3476625" cy="381000"/>
+            <a:off x="6715125" y="1533525"/>
+            <a:ext cx="2076450" cy="514350"/>
           </a:xfrm>
           <a:prstGeom prst="rect">
             <a:avLst/>
@@ -53931,7 +53852,7 @@
               <a:spcAft>
                 <a:spcPts val="700"/>
               </a:spcAft>
-              <a:defRPr sz="1875" b="1">
+              <a:defRPr sz="1725" b="1">
                 <a:solidFill>
                   <a:srgbClr val="000000"/>
                 </a:solidFill>
@@ -53939,14 +53860,14 @@
               </a:defRPr>
             </a:pPr>
             <a:r>
-              <a:t>Пример результата</a:t>
+              <a:t>01 · Параметры</a:t>
             </a:r>
           </a:p>
         </p:txBody>
       </p:sp>
       <p:pic>
         <p:nvPicPr>
-          <p:cNvPr id="12" name="!!DemoContent" descr="ped-example.png"/>
+          <p:cNvPr id="11" name="CoolingParameters" descr="ped-parameters.png"/>
           <p:cNvPicPr>
             <a:picLocks noChangeAspect="1"/>
           </p:cNvPicPr>
@@ -53961,8 +53882,8 @@
         </p:blipFill>
         <p:spPr>
           <a:xfrm>
-            <a:off x="7848600" y="2248268"/>
-            <a:ext cx="3495674" cy="2742463"/>
+            <a:off x="6890321" y="2047875"/>
+            <a:ext cx="1716531" cy="3714750"/>
           </a:xfrm>
           <a:prstGeom prst="rect">
             <a:avLst/>
@@ -53971,14 +53892,45 @@
       </p:pic>
       <p:sp>
         <p:nvSpPr>
-          <p:cNvPr id="13" name="CoolingResult"/>
-          <p:cNvSpPr txBox="1"/>
+          <p:cNvPr id="12" name="!!DemoWindow"/>
+          <p:cNvSpPr/>
           <p:nvPr/>
         </p:nvSpPr>
         <p:spPr>
           <a:xfrm>
-            <a:off x="7877175" y="5267325"/>
-            <a:ext cx="3429000" cy="619125"/>
+            <a:off x="9096375" y="1390650"/>
+            <a:ext cx="2428875" cy="4505325"/>
+          </a:xfrm>
+          <a:prstGeom prst="roundRect">
+            <a:avLst>
+              <a:gd name="adj" fmla="val 3500"/>
+            </a:avLst>
+          </a:prstGeom>
+          <a:solidFill>
+            <a:srgbClr val="FFFFFF"/>
+          </a:solidFill>
+          <a:ln>
+            <a:noFill/>
+          </a:ln>
+        </p:spPr>
+        <p:txBody>
+          <a:bodyPr rtlCol="0" anchor="ctr"/>
+          <a:lstStyle/>
+          <a:p>
+            <a:pPr algn="ctr"/>
+          </a:p>
+        </p:txBody>
+      </p:sp>
+      <p:sp>
+        <p:nvSpPr>
+          <p:cNvPr id="13" name="!!DemoCaption"/>
+          <p:cNvSpPr txBox="1"/>
+          <p:nvPr/>
+        </p:nvSpPr>
+        <p:spPr>
+          <a:xfrm>
+            <a:off x="9239250" y="1533525"/>
+            <a:ext cx="2143125" cy="619125"/>
           </a:xfrm>
           <a:prstGeom prst="rect">
             <a:avLst/>
@@ -53998,7 +53950,74 @@
               <a:spcAft>
                 <a:spcPts val="700"/>
               </a:spcAft>
-              <a:defRPr sz="3450" b="1">
+              <a:defRPr sz="1725" b="1">
+                <a:solidFill>
+                  <a:srgbClr val="000000"/>
+                </a:solidFill>
+                <a:latin typeface="Arial"/>
+              </a:defRPr>
+            </a:pPr>
+            <a:r>
+              <a:t>02 · Токи и результат</a:t>
+            </a:r>
+          </a:p>
+        </p:txBody>
+      </p:sp>
+      <p:pic>
+        <p:nvPicPr>
+          <p:cNvPr id="14" name="!!DemoContent" descr="ped-example.png"/>
+          <p:cNvPicPr>
+            <a:picLocks noChangeAspect="1"/>
+          </p:cNvPicPr>
+          <p:nvPr/>
+        </p:nvPicPr>
+        <p:blipFill>
+          <a:blip r:embed="rId3"/>
+          <a:srcRect/>
+          <a:stretch>
+            <a:fillRect/>
+          </a:stretch>
+        </p:blipFill>
+        <p:spPr>
+          <a:xfrm>
+            <a:off x="9229725" y="2657054"/>
+            <a:ext cx="2162175" cy="1696291"/>
+          </a:xfrm>
+          <a:prstGeom prst="rect">
+            <a:avLst/>
+          </a:prstGeom>
+        </p:spPr>
+      </p:pic>
+      <p:sp>
+        <p:nvSpPr>
+          <p:cNvPr id="15" name="CoolingResult"/>
+          <p:cNvSpPr txBox="1"/>
+          <p:nvPr/>
+        </p:nvSpPr>
+        <p:spPr>
+          <a:xfrm>
+            <a:off x="9267825" y="5048250"/>
+            <a:ext cx="2105025" cy="552450"/>
+          </a:xfrm>
+          <a:prstGeom prst="rect">
+            <a:avLst/>
+          </a:prstGeom>
+          <a:noFill/>
+        </p:spPr>
+        <p:txBody>
+          <a:bodyPr wrap="square" lIns="0" rIns="0" tIns="0" bIns="0">
+            <a:spAutoFit/>
+          </a:bodyPr>
+          <a:lstStyle/>
+          <a:p>
+            <a:pPr>
+              <a:lnSpc>
+                <a:spcPct val="104000"/>
+              </a:lnSpc>
+              <a:spcAft>
+                <a:spcPts val="700"/>
+              </a:spcAft>
+              <a:defRPr sz="2400" b="1">
                 <a:solidFill>
                   <a:srgbClr val="000000"/>
                 </a:solidFill>
@@ -54013,14 +54032,14 @@
       </p:sp>
       <p:sp>
         <p:nvSpPr>
-          <p:cNvPr id="14" name="Text_13"/>
+          <p:cNvPr id="16" name="Text_15"/>
           <p:cNvSpPr txBox="1"/>
           <p:nvPr/>
         </p:nvSpPr>
         <p:spPr>
           <a:xfrm>
-            <a:off x="781050" y="6029325"/>
-            <a:ext cx="10477500" cy="228600"/>
+            <a:off x="781050" y="6048375"/>
+            <a:ext cx="10668000" cy="228600"/>
           </a:xfrm>
           <a:prstGeom prst="rect">
             <a:avLst/>
@@ -54048,14 +54067,14 @@
               </a:defRPr>
             </a:pPr>
             <a:r>
-              <a:t>Учебный пример. В работе используются данные конкретного оборудования.</a:t>
+              <a:t>Учебный пример. Параметры и токи в работе — по данным конкретного оборудования.</a:t>
             </a:r>
           </a:p>
         </p:txBody>
       </p:sp>
       <p:sp>
         <p:nvSpPr>
-          <p:cNvPr id="15" name="!!Rule"/>
+          <p:cNvPr id="17" name="!!Rule"/>
           <p:cNvSpPr/>
           <p:nvPr/>
         </p:nvSpPr>
@@ -54084,7 +54103,7 @@
       </p:sp>
       <p:sp>
         <p:nvSpPr>
-          <p:cNvPr id="16" name="!!Section"/>
+          <p:cNvPr id="18" name="!!Section"/>
           <p:cNvSpPr txBox="1"/>
           <p:nvPr/>
         </p:nvSpPr>
@@ -54126,7 +54145,7 @@
       </p:sp>
       <p:sp>
         <p:nvSpPr>
-          <p:cNvPr id="17" name="!!Footer"/>
+          <p:cNvPr id="19" name="!!Footer"/>
           <p:cNvSpPr txBox="1"/>
           <p:nvPr/>
         </p:nvSpPr>
@@ -54168,7 +54187,7 @@
       </p:sp>
       <p:sp>
         <p:nvSpPr>
-          <p:cNvPr id="18" name="SlideNumber"/>
+          <p:cNvPr id="20" name="SlideNumber"/>
           <p:cNvSpPr txBox="1"/>
           <p:nvPr/>
         </p:nvSpPr>
@@ -54210,8 +54229,8 @@
       </p:sp>
       <p:sp>
         <p:nvSpPr>
-          <p:cNvPr id="19" name="!!BackToOverview">
-            <a:hlinkClick action="ppaction://hlinksldjump" r:id="rId4"/>
+          <p:cNvPr id="21" name="!!BackToOverview">
+            <a:hlinkClick action="ppaction://hlinksldjump" r:id="rId5"/>
           </p:cNvPr>
           <p:cNvSpPr txBox="1"/>
           <p:nvPr/>

</xml_diff>

<commit_message>
Add Musa Yakupov author introduction with approved portrait
</commit_message>
<xml_diff>
--- a/presentation/operator-dng-revision2/OperatorDNG_Presentation_Revision2.pptx
+++ b/presentation/operator-dng-revision2/OperatorDNG_Presentation_Revision2.pptx
@@ -8,6 +8,7 @@
     <p:sldId id="256" r:id="rId7"/>
     <p:sldId id="257" r:id="rId9"/>
     <p:sldId id="258" r:id="rId10"/>
+    <p:sldId id="276" r:id="rId28"/>
     <p:sldId id="259" r:id="rId11"/>
     <p:sldId id="260" r:id="rId12"/>
     <p:sldId id="261" r:id="rId13"/>
@@ -25,7 +26,6 @@
     <p:sldId id="273" r:id="rId25"/>
     <p:sldId id="274" r:id="rId26"/>
     <p:sldId id="275" r:id="rId27"/>
-    <p:sldId id="276" r:id="rId28"/>
     <p:sldId id="277" r:id="rId29"/>
   </p:sldIdLst>
   <p:sldSz cx="12191999" cy="6858000" type="screen4x3"/>
@@ -1499,13 +1499,7 @@
           <a:lstStyle/>
           <a:p>
             <a:r>
-              <a:t>Запасной скрытый слайд. Фото, ФИО, точная должность и номер цеха ещё не предоставлены. Не подставлять вымышленную личность.</a:t>
-            </a:r>
-          </a:p>
-          <a:p/>
-          <a:p>
-            <a:r>
-              <a:t>Переход по щелчку. Изображения PWA реальные; внутри PowerPoint формы не считают. Воспроизведение Morph в Microsoft PowerPoint здесь не проверено.</a:t>
+              <a:t>Якупов Муса Ильдарович. Оператор добычи нефти и газа. ООО «РН-Юганскнефтегаз», ЦДНГ-12. Портрет обработан ИИ по фотографиям автора.</a:t>
             </a:r>
           </a:p>
         </p:txBody>
@@ -7442,7 +7436,7 @@
               </a:defRPr>
             </a:pPr>
             <a:r>
-              <a:t>10</a:t>
+              <a:t>11</a:t>
             </a:r>
           </a:p>
         </p:txBody>
@@ -8051,7 +8045,7 @@
               </a:defRPr>
             </a:pPr>
             <a:r>
-              <a:t>11</a:t>
+              <a:t>12</a:t>
             </a:r>
           </a:p>
         </p:txBody>
@@ -8960,7 +8954,7 @@
               </a:defRPr>
             </a:pPr>
             <a:r>
-              <a:t>12</a:t>
+              <a:t>13</a:t>
             </a:r>
           </a:p>
         </p:txBody>
@@ -9538,7 +9532,7 @@
               </a:defRPr>
             </a:pPr>
             <a:r>
-              <a:t>13</a:t>
+              <a:t>14</a:t>
             </a:r>
           </a:p>
         </p:txBody>
@@ -10495,7 +10489,7 @@
               </a:defRPr>
             </a:pPr>
             <a:r>
-              <a:t>14</a:t>
+              <a:t>15</a:t>
             </a:r>
           </a:p>
         </p:txBody>
@@ -11183,7 +11177,7 @@
               </a:defRPr>
             </a:pPr>
             <a:r>
-              <a:t>15</a:t>
+              <a:t>16</a:t>
             </a:r>
           </a:p>
         </p:txBody>
@@ -11521,7 +11515,7 @@
               </a:defRPr>
             </a:pPr>
             <a:r>
-              <a:t>16</a:t>
+              <a:t>17</a:t>
             </a:r>
           </a:p>
         </p:txBody>
@@ -44651,7 +44645,7 @@
               </a:defRPr>
             </a:pPr>
             <a:r>
-              <a:t>17</a:t>
+              <a:t>18</a:t>
             </a:r>
           </a:p>
         </p:txBody>
@@ -45237,7 +45231,7 @@
               </a:defRPr>
             </a:pPr>
             <a:r>
-              <a:t>18</a:t>
+              <a:t>19</a:t>
             </a:r>
           </a:p>
         </p:txBody>
@@ -46014,7 +46008,7 @@
               </a:defRPr>
             </a:pPr>
             <a:r>
-              <a:t>19</a:t>
+              <a:t>20</a:t>
             </a:r>
           </a:p>
         </p:txBody>
@@ -47872,7 +47866,7 @@
               </a:defRPr>
             </a:pPr>
             <a:r>
-              <a:t>20</a:t>
+              <a:t>21</a:t>
             </a:r>
           </a:p>
         </p:txBody>
@@ -47898,7 +47892,7 @@
 </file>
 
 <file path=ppt/slides/slide21.xml><?xml version="1.0" encoding="utf-8"?>
-<p:sld xmlns:a="http://schemas.openxmlformats.org/drawingml/2006/main" xmlns:p="http://schemas.openxmlformats.org/presentationml/2006/main" xmlns:r="http://schemas.openxmlformats.org/officeDocument/2006/relationships" show="0">
+<p:sld xmlns:a="http://schemas.openxmlformats.org/drawingml/2006/main" xmlns:p="http://schemas.openxmlformats.org/presentationml/2006/main" xmlns:r="http://schemas.openxmlformats.org/officeDocument/2006/relationships">
   <p:cSld>
     <p:bg>
       <p:bgPr>
@@ -47915,16 +47909,41 @@
         <p:nvPr/>
       </p:nvGrpSpPr>
       <p:grpSpPr/>
+      <p:pic>
+        <p:nvPicPr>
+          <p:cNvPr id="2" name="!!AuthorPortrait" descr="author-portrait.png"/>
+          <p:cNvPicPr>
+            <a:picLocks noChangeAspect="1"/>
+          </p:cNvPicPr>
+          <p:nvPr/>
+        </p:nvPicPr>
+        <p:blipFill>
+          <a:blip r:embed="rId2"/>
+          <a:srcRect/>
+          <a:stretch>
+            <a:fillRect/>
+          </a:stretch>
+        </p:blipFill>
+        <p:spPr>
+          <a:xfrm>
+            <a:off x="0" y="0"/>
+            <a:ext cx="12192000" cy="6858000"/>
+          </a:xfrm>
+          <a:prstGeom prst="rect">
+            <a:avLst/>
+          </a:prstGeom>
+        </p:spPr>
+      </p:pic>
       <p:sp>
         <p:nvSpPr>
-          <p:cNvPr id="2" name="!!Headline"/>
+          <p:cNvPr id="3" name="!!AuthorName"/>
           <p:cNvSpPr txBox="1"/>
           <p:nvPr/>
         </p:nvSpPr>
         <p:spPr>
           <a:xfrm>
-            <a:off x="685800" y="1476375"/>
-            <a:ext cx="7239000" cy="1619250"/>
+            <a:off x="723900" y="1695450"/>
+            <a:ext cx="6191250" cy="1476375"/>
           </a:xfrm>
           <a:prstGeom prst="rect">
             <a:avLst/>
@@ -47944,7 +47963,7 @@
               <a:spcAft>
                 <a:spcPts val="700"/>
               </a:spcAft>
-              <a:defRPr sz="4200" b="1">
+              <a:defRPr sz="4050" b="1">
                 <a:solidFill>
                   <a:srgbClr val="FFFFFF"/>
                 </a:solidFill>
@@ -47952,49 +47971,7 @@
               </a:defRPr>
             </a:pPr>
             <a:r>
-              <a:t>Автор проекта</a:t>
-            </a:r>
-          </a:p>
-        </p:txBody>
-      </p:sp>
-      <p:sp>
-        <p:nvSpPr>
-          <p:cNvPr id="3" name="!!Subtitle"/>
-          <p:cNvSpPr txBox="1"/>
-          <p:nvPr/>
-        </p:nvSpPr>
-        <p:spPr>
-          <a:xfrm>
-            <a:off x="723900" y="3476625"/>
-            <a:ext cx="7239000" cy="1524000"/>
-          </a:xfrm>
-          <a:prstGeom prst="rect">
-            <a:avLst/>
-          </a:prstGeom>
-          <a:noFill/>
-        </p:spPr>
-        <p:txBody>
-          <a:bodyPr wrap="square" lIns="0" rIns="0" tIns="0" bIns="0">
-            <a:spAutoFit/>
-          </a:bodyPr>
-          <a:lstStyle/>
-          <a:p>
-            <a:pPr>
-              <a:lnSpc>
-                <a:spcPct val="104000"/>
-              </a:lnSpc>
-              <a:spcAft>
-                <a:spcPts val="700"/>
-              </a:spcAft>
-              <a:defRPr sz="2025" b="0">
-                <a:solidFill>
-                  <a:srgbClr val="B7B7B7"/>
-                </a:solidFill>
-                <a:latin typeface="Arial"/>
-              </a:defRPr>
-            </a:pPr>
-            <a:r>
-              <a:t>[ФИО]</a:t>
+              <a:t>Якупов Муса</a:t>
             </a:r>
           </a:p>
           <a:p>
@@ -48005,119 +47982,29 @@
               <a:spcAft>
                 <a:spcPts val="700"/>
               </a:spcAft>
-              <a:defRPr sz="2025" b="0">
+              <a:defRPr sz="4050" b="1">
                 <a:solidFill>
-                  <a:srgbClr val="B7B7B7"/>
+                  <a:srgbClr val="FFFFFF"/>
                 </a:solidFill>
                 <a:latin typeface="Arial"/>
               </a:defRPr>
             </a:pPr>
             <a:r>
-              <a:t>[Должность · номер цеха]</a:t>
+              <a:t>Ильдарович</a:t>
             </a:r>
           </a:p>
         </p:txBody>
       </p:sp>
       <p:sp>
         <p:nvSpPr>
-          <p:cNvPr id="4" name="PortraitFrame"/>
+          <p:cNvPr id="4" name="AuthorAccent"/>
           <p:cNvSpPr/>
           <p:nvPr/>
         </p:nvSpPr>
         <p:spPr>
           <a:xfrm>
-            <a:off x="8334375" y="1524000"/>
-            <a:ext cx="2857500" cy="4286250"/>
-          </a:xfrm>
-          <a:prstGeom prst="rect">
-            <a:avLst/>
-          </a:prstGeom>
-          <a:solidFill>
-            <a:srgbClr val="242424"/>
-          </a:solidFill>
-          <a:ln>
-            <a:noFill/>
-          </a:ln>
-        </p:spPr>
-        <p:txBody>
-          <a:bodyPr rtlCol="0" anchor="ctr"/>
-          <a:lstStyle/>
-          <a:p>
-            <a:pPr algn="ctr"/>
-          </a:p>
-        </p:txBody>
-      </p:sp>
-      <p:sp>
-        <p:nvSpPr>
-          <p:cNvPr id="5" name="Text_4"/>
-          <p:cNvSpPr txBox="1"/>
-          <p:nvPr/>
-        </p:nvSpPr>
-        <p:spPr>
-          <a:xfrm>
-            <a:off x="8763000" y="3238500"/>
-            <a:ext cx="2047875" cy="1143000"/>
-          </a:xfrm>
-          <a:prstGeom prst="rect">
-            <a:avLst/>
-          </a:prstGeom>
-          <a:noFill/>
-        </p:spPr>
-        <p:txBody>
-          <a:bodyPr wrap="square" lIns="0" rIns="0" tIns="0" bIns="0">
-            <a:spAutoFit/>
-          </a:bodyPr>
-          <a:lstStyle/>
-          <a:p>
-            <a:pPr>
-              <a:lnSpc>
-                <a:spcPct val="104000"/>
-              </a:lnSpc>
-              <a:spcAft>
-                <a:spcPts val="700"/>
-              </a:spcAft>
-              <a:defRPr sz="2025" b="0">
-                <a:solidFill>
-                  <a:srgbClr val="B7B7B7"/>
-                </a:solidFill>
-                <a:latin typeface="Arial"/>
-              </a:defRPr>
-            </a:pPr>
-            <a:r>
-              <a:t>Фото автора</a:t>
-            </a:r>
-          </a:p>
-          <a:p>
-            <a:pPr>
-              <a:lnSpc>
-                <a:spcPct val="104000"/>
-              </a:lnSpc>
-              <a:spcAft>
-                <a:spcPts val="700"/>
-              </a:spcAft>
-              <a:defRPr sz="2025" b="0">
-                <a:solidFill>
-                  <a:srgbClr val="B7B7B7"/>
-                </a:solidFill>
-                <a:latin typeface="Arial"/>
-              </a:defRPr>
-            </a:pPr>
-            <a:r>
-              <a:t>пока не получено</a:t>
-            </a:r>
-          </a:p>
-        </p:txBody>
-      </p:sp>
-      <p:sp>
-        <p:nvSpPr>
-          <p:cNvPr id="6" name="!!Rule"/>
-          <p:cNvSpPr/>
-          <p:nvPr/>
-        </p:nvSpPr>
-        <p:spPr>
-          <a:xfrm>
-            <a:off x="666750" y="590550"/>
-            <a:ext cx="10858500" cy="38100"/>
+            <a:off x="762000" y="3409950"/>
+            <a:ext cx="1047749" cy="47625"/>
           </a:xfrm>
           <a:prstGeom prst="rect">
             <a:avLst/>
@@ -48139,7 +48026,158 @@
       </p:sp>
       <p:sp>
         <p:nvSpPr>
-          <p:cNvPr id="7" name="!!Section"/>
+          <p:cNvPr id="5" name="AuthorRole"/>
+          <p:cNvSpPr txBox="1"/>
+          <p:nvPr/>
+        </p:nvSpPr>
+        <p:spPr>
+          <a:xfrm>
+            <a:off x="762000" y="3819524"/>
+            <a:ext cx="5953125" cy="952500"/>
+          </a:xfrm>
+          <a:prstGeom prst="rect">
+            <a:avLst/>
+          </a:prstGeom>
+          <a:noFill/>
+        </p:spPr>
+        <p:txBody>
+          <a:bodyPr wrap="square" lIns="0" rIns="0" tIns="0" bIns="0">
+            <a:spAutoFit/>
+          </a:bodyPr>
+          <a:lstStyle/>
+          <a:p>
+            <a:pPr>
+              <a:lnSpc>
+                <a:spcPct val="104000"/>
+              </a:lnSpc>
+              <a:spcAft>
+                <a:spcPts val="700"/>
+              </a:spcAft>
+              <a:defRPr sz="2625" b="0">
+                <a:solidFill>
+                  <a:srgbClr val="FFFFFF"/>
+                </a:solidFill>
+                <a:latin typeface="Arial"/>
+              </a:defRPr>
+            </a:pPr>
+            <a:r>
+              <a:t>Оператор добычи</a:t>
+            </a:r>
+          </a:p>
+          <a:p>
+            <a:pPr>
+              <a:lnSpc>
+                <a:spcPct val="104000"/>
+              </a:lnSpc>
+              <a:spcAft>
+                <a:spcPts val="700"/>
+              </a:spcAft>
+              <a:defRPr sz="2625" b="0">
+                <a:solidFill>
+                  <a:srgbClr val="FFFFFF"/>
+                </a:solidFill>
+                <a:latin typeface="Arial"/>
+              </a:defRPr>
+            </a:pPr>
+            <a:r>
+              <a:t>нефти и газа</a:t>
+            </a:r>
+          </a:p>
+        </p:txBody>
+      </p:sp>
+      <p:sp>
+        <p:nvSpPr>
+          <p:cNvPr id="6" name="AuthorOrganization"/>
+          <p:cNvSpPr txBox="1"/>
+          <p:nvPr/>
+        </p:nvSpPr>
+        <p:spPr>
+          <a:xfrm>
+            <a:off x="762000" y="5219700"/>
+            <a:ext cx="5953125" cy="762000"/>
+          </a:xfrm>
+          <a:prstGeom prst="rect">
+            <a:avLst/>
+          </a:prstGeom>
+          <a:noFill/>
+        </p:spPr>
+        <p:txBody>
+          <a:bodyPr wrap="square" lIns="0" rIns="0" tIns="0" bIns="0">
+            <a:spAutoFit/>
+          </a:bodyPr>
+          <a:lstStyle/>
+          <a:p>
+            <a:pPr>
+              <a:lnSpc>
+                <a:spcPct val="104000"/>
+              </a:lnSpc>
+              <a:spcAft>
+                <a:spcPts val="700"/>
+              </a:spcAft>
+              <a:defRPr sz="2175" b="0">
+                <a:solidFill>
+                  <a:srgbClr val="FFCD00"/>
+                </a:solidFill>
+                <a:latin typeface="Arial"/>
+              </a:defRPr>
+            </a:pPr>
+            <a:r>
+              <a:t>ООО «РН-Юганскнефтегаз»</a:t>
+            </a:r>
+          </a:p>
+          <a:p>
+            <a:pPr>
+              <a:lnSpc>
+                <a:spcPct val="104000"/>
+              </a:lnSpc>
+              <a:spcAft>
+                <a:spcPts val="700"/>
+              </a:spcAft>
+              <a:defRPr sz="2175" b="0">
+                <a:solidFill>
+                  <a:srgbClr val="FFCD00"/>
+                </a:solidFill>
+                <a:latin typeface="Arial"/>
+              </a:defRPr>
+            </a:pPr>
+            <a:r>
+              <a:t>ЦДНГ-12</a:t>
+            </a:r>
+          </a:p>
+        </p:txBody>
+      </p:sp>
+      <p:sp>
+        <p:nvSpPr>
+          <p:cNvPr id="7" name="!!Rule"/>
+          <p:cNvSpPr/>
+          <p:nvPr/>
+        </p:nvSpPr>
+        <p:spPr>
+          <a:xfrm>
+            <a:off x="666750" y="590550"/>
+            <a:ext cx="5143500" cy="38100"/>
+          </a:xfrm>
+          <a:prstGeom prst="rect">
+            <a:avLst/>
+          </a:prstGeom>
+          <a:solidFill>
+            <a:srgbClr val="FFCD00"/>
+          </a:solidFill>
+          <a:ln>
+            <a:noFill/>
+          </a:ln>
+        </p:spPr>
+        <p:txBody>
+          <a:bodyPr rtlCol="0" anchor="ctr"/>
+          <a:lstStyle/>
+          <a:p>
+            <a:pPr algn="ctr"/>
+          </a:p>
+        </p:txBody>
+      </p:sp>
+      <p:sp>
+        <p:nvSpPr>
+          <p:cNvPr id="8" name="!!Section"/>
           <p:cNvSpPr txBox="1"/>
           <p:nvPr/>
         </p:nvSpPr>
@@ -48174,14 +48212,14 @@
               </a:defRPr>
             </a:pPr>
             <a:r>
-              <a:t>ОПЕРАТОР ДНГ / АВТОР / ЗАПАСНОЙ</a:t>
+              <a:t>ОПЕРАТОР ДНГ / АВТОР ПРОЕКТА</a:t>
             </a:r>
           </a:p>
         </p:txBody>
       </p:sp>
       <p:sp>
         <p:nvSpPr>
-          <p:cNvPr id="8" name="!!Footer"/>
+          <p:cNvPr id="9" name="!!Footer"/>
           <p:cNvSpPr txBox="1"/>
           <p:nvPr/>
         </p:nvSpPr>
@@ -48223,7 +48261,7 @@
       </p:sp>
       <p:sp>
         <p:nvSpPr>
-          <p:cNvPr id="9" name="SlideNumber"/>
+          <p:cNvPr id="10" name="SlideNumber"/>
           <p:cNvSpPr txBox="1"/>
           <p:nvPr/>
         </p:nvSpPr>
@@ -48258,7 +48296,7 @@
               </a:defRPr>
             </a:pPr>
             <a:r>
-              <a:t>21</a:t>
+              <a:t>04</a:t>
             </a:r>
           </a:p>
         </p:txBody>
@@ -48268,9 +48306,18 @@
   <p:clrMapOvr>
     <a:masterClrMapping/>
   </p:clrMapOvr>
-  <p:transition advClick="1">
-    <p:fade/>
-  </p:transition>
+  <mc:AlternateContent xmlns:mc="http://schemas.openxmlformats.org/markup-compatibility/2006" xmlns:p159="http://schemas.microsoft.com/office/powerpoint/2015/09/main" xmlns:p14="http://schemas.microsoft.com/office/powerpoint/2010/main">
+    <mc:Choice Requires="p159">
+      <p:transition advClick="1" spd="slow" p14:dur="1400">
+        <p159:morph option="byObject"/>
+      </p:transition>
+    </mc:Choice>
+    <mc:Fallback>
+      <p:transition advClick="1" spd="slow">
+        <p:push dir="l"/>
+      </p:transition>
+    </mc:Fallback>
+  </mc:AlternateContent>
 </p:sld>
 </file>
 
@@ -51206,7 +51253,7 @@
               </a:defRPr>
             </a:pPr>
             <a:r>
-              <a:t>04</a:t>
+              <a:t>05</a:t>
             </a:r>
           </a:p>
         </p:txBody>
@@ -51857,7 +51904,7 @@
               </a:defRPr>
             </a:pPr>
             <a:r>
-              <a:t>05</a:t>
+              <a:t>06</a:t>
             </a:r>
           </a:p>
         </p:txBody>
@@ -52628,7 +52675,7 @@
               </a:defRPr>
             </a:pPr>
             <a:r>
-              <a:t>06</a:t>
+              <a:t>07</a:t>
             </a:r>
           </a:p>
         </p:txBody>
@@ -53412,7 +53459,7 @@
               </a:defRPr>
             </a:pPr>
             <a:r>
-              <a:t>07</a:t>
+              <a:t>08</a:t>
             </a:r>
           </a:p>
         </p:txBody>
@@ -54222,7 +54269,7 @@
               </a:defRPr>
             </a:pPr>
             <a:r>
-              <a:t>08</a:t>
+              <a:t>09</a:t>
             </a:r>
           </a:p>
         </p:txBody>
@@ -55131,7 +55178,7 @@
               </a:defRPr>
             </a:pPr>
             <a:r>
-              <a:t>09</a:t>
+              <a:t>10</a:t>
             </a:r>
           </a:p>
         </p:txBody>

</xml_diff>